<commit_message>
Title the project "Pakistani Banknote Reader"
Replaces the one-word name in everything people read: site, README, report,
slides, LinkedIn text and model card. Code names, file paths and URLs stay,
so no link changes.

Co-Authored-By: Claude Opus 5.5 <noreply@anthropic.com>
</commit_message>
<xml_diff>
--- a/docs/slides/BoltaNote_slides.pptx
+++ b/docs/slides/BoltaNote_slides.pptx
@@ -513,7 +513,7 @@
           <a:lstStyle/>
           <a:p>
             <a:r>
-              <a:t>Assalam o alaikum. I'm Hassan Ali Mehdi, and this is BoltaNote, which means 'the talking note'. You point your phone at a Pakistani banknote, and it tells you the value out loud, in Urdu.</a:t>
+              <a:t>Assalam o alaikum. I'm Hassan Ali Mehdi, and this is a Pakistani banknote reader for blind people. You point your phone at a note, and it tells you the value out loud, in Urdu.</a:t>
             </a:r>
           </a:p>
         </p:txBody>
@@ -863,7 +863,7 @@
           <a:lstStyle/>
           <a:p>
             <a:r>
-              <a:t>BoltaNote is just a web page. It reads the camera four times a second and speaks the value in Urdu or English, with a recorded voice, so it works even on phones that have no Urdu speech. It stays silent when it's unsure, because saying a wrong amount is worse than saying nothing. Once loaded, it works offline, and it also vibrates a code and works with screen readers.</a:t>
+              <a:t>The reader is just a web page. It reads the camera four times a second and speaks the value in Urdu or English, with a recorded voice, so it works even on phones that have no Urdu speech. It stays silent when it's unsure, because saying a wrong amount is worse than saying nothing. Once loaded, it works offline, and it also vibrates a code and works with screen readers.</a:t>
             </a:r>
           </a:p>
         </p:txBody>

</xml_diff>